<commit_message>
Recheck Semester 1 Week 1: slide wording, FrozenLake link and exercise text
- Slides 26, 28: grammar and tense fixes; quote marks in Brooks paper title
- Slide 22: restore the FrozenLake link as a pointer to the course website
  (Week 11 practical), keeping the Kaggle original as a link
- Slide 20: photo caption "probably Milner"; Shannon link formatted like the others
- Slides 5, 6, 21, 23, 27, 30, 34, 36: small wording and consistency fixes
- Notebooks 02 and 03: "like punctuation attached" wording

Co-Authored-By: Claude Opus 5.5 <noreply@anthropic.com>
Claude-Session: https://claude.ai/code/session_01EAaejpNJcgrNybkHr1Pd8Y

[skip ci]
</commit_message>
<xml_diff>
--- a/content/Lectures/Semester 1/Week 1/1 Lecture/1.1 Introduction to Frontiers in AI and Data Science (Lecture).pptx
+++ b/content/Lectures/Semester 1/Week 1/1 Lecture/1.1 Introduction to Frontiers in AI and Data Science (Lecture).pptx
@@ -5723,19 +5723,24 @@
               <a:t>7) </a:t>
             </a:r>
             <a:r>
-              <a:rPr lang="en-GB" sz="2000" u="sng" dirty="0" err="1">
-                <a:hlinkClick r:id="rId9"/>
+              <a:rPr lang="en-US" altLang="en-US" sz="2000" dirty="0">
+                <a:solidFill>
+                  <a:srgbClr val="0B0080"/>
+                </a:solidFill>
+                <a:latin typeface="Arial" charset="0"/>
+                <a:cs typeface="Arial" charset="0"/>
+                <a:hlinkClick r:id="rId9" tooltip="Claude Shannon"/>
               </a:rPr>
-              <a:t>Dr.</a:t>
-            </a:r>
-            <a:r>
-              <a:rPr lang="en-GB" sz="2000" u="sng" dirty="0">
-                <a:hlinkClick r:id="rId9"/>
+              <a:t>Dr. Claude Shannon</a:t>
+            </a:r>
+            <a:r>
+              <a:rPr lang="en-US" altLang="en-US" sz="2000" dirty="0">
+                <a:solidFill>
+                  <a:srgbClr val="0B0080"/>
+                </a:solidFill>
+                <a:latin typeface="Arial" charset="0"/>
+                <a:cs typeface="Arial" charset="0"/>
               </a:rPr>
-              <a:t> Claude Shannon</a:t>
-            </a:r>
-            <a:r>
-              <a:rPr lang="en-GB" sz="2000" u="sng" dirty="0"/>
               <a:t> (IT)</a:t>
             </a:r>
             <a:endParaRPr lang="en-GB" altLang="en-US" sz="2000" dirty="0"/>
@@ -5898,7 +5903,7 @@
           <a:p>
             <a:r>
               <a:rPr sz="1000" i="1"/>
-              <a:t>Back: Selfridge, Rochester, Minsky, McCarthy; front: Solomonoff, Milner, Shannon</a:t>
+              <a:t>Back: Selfridge, Rochester, Minsky, McCarthy; front: Solomonoff, probably Milner, Shannon</a:t>
             </a:r>
           </a:p>
         </p:txBody>
@@ -5981,7 +5986,7 @@
                   <a:srgbClr val="0070C0"/>
                 </a:solidFill>
               </a:rPr>
-              <a:t>Two major themes that have driven AI development from the start to today are: Game-play and Robot</a:t>
+              <a:t>Two major themes that have driven AI development from the start to today are: game-playing and robotics</a:t>
             </a:r>
           </a:p>
           <a:p>
@@ -6234,6 +6239,51 @@
           </a:extLst>
         </p:spPr>
       </p:pic>
+      <p:sp>
+        <p:nvSpPr>
+          <p:cNvPr id="6" name="TextBox 5">
+            <a:extLst>
+              <a:ext uri="{FF2B5EF4-FFF2-40B4-BE49-F238E27FC236}">
+                <a16:creationId xmlns:a16="http://schemas.microsoft.com/office/drawing/2014/main" id="{1CB244AA-5641-4E15-8E49-746009649A16}"/>
+              </a:ext>
+            </a:extLst>
+          </p:cNvPr>
+          <p:cNvSpPr txBox="1"/>
+          <p:nvPr/>
+        </p:nvSpPr>
+        <p:spPr>
+          <a:xfrm>
+            <a:off x="1295400" y="5230863"/>
+            <a:ext cx="3048000" cy="923330"/>
+          </a:xfrm>
+          <a:prstGeom prst="rect">
+            <a:avLst/>
+          </a:prstGeom>
+          <a:noFill/>
+        </p:spPr>
+        <p:txBody>
+          <a:bodyPr wrap="square">
+            <a:spAutoFit/>
+          </a:bodyPr>
+          <a:lstStyle/>
+          <a:p>
+            <a:r>
+              <a:rPr lang="en-GB" dirty="0"/>
+              <a:t>Week 11 practical: FrozenLake RL notebook on the course website (original: </a:t>
+            </a:r>
+            <a:r>
+              <a:rPr lang="en-GB" dirty="0">
+                <a:hlinkClick r:id="rId3"/>
+              </a:rPr>
+              <a:t>Kaggle</a:t>
+            </a:r>
+            <a:r>
+              <a:rPr lang="en-GB" dirty="0"/>
+              <a:t>)</a:t>
+            </a:r>
+          </a:p>
+        </p:txBody>
+      </p:sp>
     </p:spTree>
     <p:extLst>
       <p:ext uri="{BB962C8B-B14F-4D97-AF65-F5344CB8AC3E}">
@@ -6372,7 +6422,7 @@
             </a:pPr>
             <a:r>
               <a:rPr lang="en-GB" altLang="en-US" sz="2000" b="1" dirty="0"/>
-              <a:t>Natural language Processing</a:t>
+              <a:t>Natural Language Processing</a:t>
             </a:r>
             <a:r>
               <a:rPr lang="en-GB" altLang="en-US" sz="2000" dirty="0"/>
@@ -6900,7 +6950,7 @@
             <a:pPr lvl="1"/>
             <a:r>
               <a:rPr lang="en-GB" altLang="en-US" sz="1800" dirty="0"/>
-              <a:t>However, the fundamental issue about uncertainty (today we call it probability and fuzzy logic) and capability of dealing with big size data aren’t really solved at all in that time.   </a:t>
+              <a:t>However, the fundamental issue about uncertainty (today we call it probability and fuzzy logic) and capability of dealing with big size data were not really solved at that time.   </a:t>
             </a:r>
           </a:p>
           <a:p>
@@ -6992,7 +7042,7 @@
           <a:p>
             <a:r>
               <a:rPr lang="en-GB" altLang="en-US" b="1" dirty="0"/>
-              <a:t>the second AI winter 1987−1993</a:t>
+              <a:t>The second AI winter 1987−1993</a:t>
             </a:r>
           </a:p>
           <a:p>
@@ -7130,7 +7180,7 @@
             </a:pPr>
             <a:r>
               <a:rPr lang="en-GB" altLang="en-US" sz="2000" dirty="0"/>
-              <a:t>A completely new approach to AI, based on robotics, has been proposed by Brooks in his paper "Elephants Don't Play Chess”, based on the belief that, to show real intelligence, a machine needs to have a body — it needs to perceive, move, survive and deal with the world.</a:t>
+              <a:t>A completely new approach to AI, based on robotics, was proposed by Brooks in his paper “Elephants Don't Play Chess”, based on the belief that, to show real intelligence, a machine needs to have a body — it needs to perceive, move, survive and deal with the world.</a:t>
             </a:r>
           </a:p>
           <a:p>
@@ -7447,7 +7497,7 @@
           <a:p>
             <a:r>
               <a:rPr lang="en-GB" altLang="en-US" dirty="0"/>
-              <a:t>Brief </a:t>
+              <a:t>A bit of </a:t>
             </a:r>
             <a:r>
               <a:rPr lang="en-US" altLang="en-US" dirty="0"/>
@@ -11164,7 +11214,7 @@
                           <a:ea typeface="Calibri"/>
                           <a:cs typeface="Times New Roman"/>
                         </a:rPr>
-                        <a:t>14 -15</a:t>
+                        <a:t>14–15</a:t>
                       </a:r>
                     </a:p>
                   </a:txBody>
@@ -11786,6 +11836,10 @@
                 <a:hlinkClick r:id="rId4"/>
               </a:rPr>
               <a:t>https://www.pandorabots.com/mitsuku/</a:t>
+            </a:r>
+            <a:r>
+              <a:rPr lang="en-GB" sz="2000" dirty="0"/>
+              <a:t> (now Kuki)</a:t>
             </a:r>
             <a:endParaRPr lang="en-GB" sz="2000" dirty="0"/>
           </a:p>
@@ -14173,7 +14227,7 @@
                           <a:ea typeface="Calibri"/>
                           <a:cs typeface="Times New Roman"/>
                         </a:rPr>
-                        <a:t>14 -15</a:t>
+                        <a:t>14–15</a:t>
                       </a:r>
                     </a:p>
                   </a:txBody>
@@ -14590,7 +14644,7 @@
           <a:p>
             <a:r>
               <a:rPr lang="en-GB" dirty="0"/>
-              <a:t>MLO1: Explain fundamental concepts in ML/ AI</a:t>
+              <a:t>MLO1: Explain fundamental concepts in ML/AI</a:t>
             </a:r>
           </a:p>
           <a:p>

</xml_diff>